<commit_message>
Switch all demo links to the Hugging Face Space
Point every live-demo reference at the HF Space (full model, live Grad-CAM)
instead of the Render lite URL: README (new Live demo line), report main.tex +
submission tex, phase3_submission.md, presentation_outline.md (+ submission copy),
Codes link file. Reframed presentation demo/deployment prose from Render/TFLite to
HF Spaces full-TF with live Grad-CAM, and rebuilt DTCF_Presentation.pptx and both
zips.

Co-Authored-By: Claude Opus 4.8 <noreply@anthropic.com>
</commit_message>
<xml_diff>
--- a/docs/submission/Presentations/DTCF_Presentation.pptx
+++ b/docs/submission/Presentations/DTCF_Presentation.pptx
@@ -3409,7 +3409,7 @@
                 </a:solidFill>
                 <a:latin typeface="Calibri"/>
               </a:rPr>
-              <a:t>Live demo:  https://document-type-classification-framework.onrender.com</a:t>
+              <a:t>Live demo:  https://ashokcse-document-type-classification-framework.hf.space</a:t>
             </a:r>
           </a:p>
           <a:p>
@@ -3731,7 +3731,7 @@
                 </a:solidFill>
                 <a:latin typeface="Calibri"/>
               </a:rPr>
-              <a:t>•  Trained ResNet50 → TensorFlow Lite + lightweight LiteRT runtime (no full TF).</a:t>
+              <a:t>•  Deployed FREE on Hugging Face Spaces (full TensorFlow, ~16 GB CPU).</a:t>
             </a:r>
           </a:p>
           <a:p>
@@ -3747,7 +3747,7 @@
                 </a:solidFill>
                 <a:latin typeface="Calibri"/>
               </a:rPr>
-              <a:t>•  Fits a 512 MB free-tier container; inference runs in a worker thread (stays responsive).</a:t>
+              <a:t>•  Serves the UI + API and a LIVE Grad-CAM overlay + uncertainty per prediction.</a:t>
             </a:r>
           </a:p>
           <a:p>
@@ -3763,7 +3763,7 @@
                 </a:solidFill>
                 <a:latin typeface="Calibri"/>
               </a:rPr>
-              <a:t>•  FastAPI: browser upload UI + POST /predict JSON API; one-click sample pages.</a:t>
+              <a:t>•  Non-blocking worker-thread inference; FastAPI POST /predict JSON API.</a:t>
             </a:r>
           </a:p>
           <a:p>
@@ -3779,7 +3779,7 @@
                 </a:solidFill>
                 <a:latin typeface="Calibri"/>
               </a:rPr>
-              <a:t>•  Pure-NumPy preprocessing keeps the lite path TensorFlow-free.</a:t>
+              <a:t>•  Also a 512 MB TFLite build (Render free) — smaller, but no Grad-CAM there.</a:t>
             </a:r>
           </a:p>
         </p:txBody>
@@ -3862,7 +3862,7 @@
                 </a:solidFill>
                 <a:latin typeface="Calibri"/>
               </a:rPr>
-              <a:t>▶  Live demo:  https://document-type-classification-framework.onrender.com</a:t>
+              <a:t>▶  Live demo:  https://ashokcse-document-type-classification-framework.hf.space</a:t>
             </a:r>
           </a:p>
         </p:txBody>
@@ -4494,7 +4494,7 @@
                 </a:solidFill>
                 <a:latin typeface="Calibri"/>
               </a:rPr>
-              <a:t>Live demo:  https://document-type-classification-framework.onrender.com</a:t>
+              <a:t>Live demo:  https://ashokcse-document-type-classification-framework.hf.space</a:t>
             </a:r>
           </a:p>
           <a:p>

</xml_diff>

<commit_message>
Point all GitHub references to the Phase 2 course repo (PR_SE26)
Switch the GitHub repo URL from Document-Type-Classification-Framework to
PR_SE26_German_Document_Type_Classification_with_CNNs across README, UI footer
(index.html), report main.tex + submission tex, phase3_submission.md,
deploy_easypanel.md, Codes link file, hf_space/Dockerfile (clone source) +
README, and the presentation (rebuilt PPTX). HF Space demo URL is unchanged.
Rebuilt Overleaf + submission zips.

Co-Authored-By: Claude Opus 4.8 <noreply@anthropic.com>
</commit_message>
<xml_diff>
--- a/docs/submission/Presentations/DTCF_Presentation.pptx
+++ b/docs/submission/Presentations/DTCF_Presentation.pptx
@@ -3425,7 +3425,7 @@
                 </a:solidFill>
                 <a:latin typeface="Calibri"/>
               </a:rPr>
-              <a:t>Code:  github.com/ashok-cse/Document-Type-Classification-Framework</a:t>
+              <a:t>Code:  github.com/ashok-cse/PR_SE26_German_Document_Type_Classification_with_CNNs</a:t>
             </a:r>
           </a:p>
         </p:txBody>
@@ -4510,7 +4510,7 @@
                 </a:solidFill>
                 <a:latin typeface="Calibri"/>
               </a:rPr>
-              <a:t>GitHub:  github.com/ashok-cse/Document-Type-Classification-Framework</a:t>
+              <a:t>GitHub:  github.com/ashok-cse/PR_SE26_German_Document_Type_Classification_with_CNNs</a:t>
             </a:r>
           </a:p>
           <a:p>

</xml_diff>